<commit_message>
chore: 添加 .DS_Store 文件并更新 PPT 文件
</commit_message>
<xml_diff>
--- a/c2d20114c647f438154704bfad849df5_3988924662079134186_m.pptx
+++ b/c2d20114c647f438154704bfad849df5_3988924662079134186_m.pptx
@@ -3408,7 +3408,7 @@
         </p:nvSpPr>
         <p:spPr>
           <a:xfrm>
-            <a:off x="8441056" y="1713888"/>
+            <a:off x="8990331" y="1372258"/>
             <a:ext cx="2980055" cy="598805"/>
           </a:xfrm>
           <a:prstGeom prst="rect">
@@ -3477,8 +3477,8 @@
           </p:nvPr>
         </p:nvGraphicFramePr>
         <p:xfrm>
-          <a:off x="283845" y="1661160"/>
-          <a:ext cx="11776075" cy="4688840"/>
+          <a:off x="284480" y="1621790"/>
+          <a:ext cx="11776075" cy="4688205"/>
         </p:xfrm>
         <a:graphic>
           <a:graphicData uri="http://schemas.openxmlformats.org/drawingml/2006/table">
@@ -3491,7 +3491,7 @@
                 <a:gridCol w="3300095"/>
                 <a:gridCol w="1600200"/>
               </a:tblGrid>
-              <a:tr h="186690">
+              <a:tr h="186055">
                 <a:tc>
                   <a:txBody>
                     <a:bodyPr/>
@@ -3847,97 +3847,6 @@
                       </a:schemeClr>
                     </a:solidFill>
                   </a:tcPr>
-                </a:tc>
-              </a:tr>
-              <a:tr h="226695">
-                <a:tc gridSpan="5">
-                  <a:txBody>
-                    <a:bodyPr/>
-                    <a:lstStyle/>
-                    <a:p>
-                      <a:pPr algn="ctr" fontAlgn="ctr"/>
-                      <a:r>
-                        <a:rPr lang="en-US" sz="1050" b="1" i="0" u="none" strike="noStrike" dirty="0">
-                          <a:solidFill>
-                            <a:srgbClr val="000000"/>
-                          </a:solidFill>
-                          <a:effectLst/>
-                          <a:latin typeface="微软雅黑" charset="-122"/>
-                          <a:ea typeface="微软雅黑" charset="-122"/>
-                        </a:rPr>
-                        <a:t>Pony Class</a:t>
-                      </a:r>
-                      <a:endParaRPr lang="en-US" sz="1050" b="1" i="0" u="none" strike="noStrike" dirty="0">
-                        <a:solidFill>
-                          <a:srgbClr val="000000"/>
-                        </a:solidFill>
-                        <a:effectLst/>
-                        <a:latin typeface="微软雅黑" charset="-122"/>
-                        <a:ea typeface="微软雅黑" charset="-122"/>
-                      </a:endParaRPr>
-                    </a:p>
-                  </a:txBody>
-                  <a:tcPr marL="2646" marR="2646" marT="2646" marB="0" anchor="ctr">
-                    <a:lnL w="12700" cap="flat" cmpd="sng" algn="ctr">
-                      <a:solidFill>
-                        <a:srgbClr val="948A54"/>
-                      </a:solidFill>
-                      <a:prstDash val="dash"/>
-                      <a:round/>
-                      <a:headEnd type="none" w="med" len="med"/>
-                      <a:tailEnd type="none" w="med" len="med"/>
-                    </a:lnL>
-                    <a:lnR w="12700" cap="flat" cmpd="sng" algn="ctr">
-                      <a:solidFill>
-                        <a:srgbClr val="948A54"/>
-                      </a:solidFill>
-                      <a:prstDash val="dash"/>
-                      <a:round/>
-                      <a:headEnd type="none" w="med" len="med"/>
-                      <a:tailEnd type="none" w="med" len="med"/>
-                    </a:lnR>
-                    <a:lnT w="12700" cap="flat" cmpd="sng" algn="ctr">
-                      <a:solidFill>
-                        <a:srgbClr val="948A54"/>
-                      </a:solidFill>
-                      <a:prstDash val="dash"/>
-                      <a:round/>
-                      <a:headEnd type="none" w="med" len="med"/>
-                      <a:tailEnd type="none" w="med" len="med"/>
-                    </a:lnT>
-                    <a:lnB w="12700" cap="flat" cmpd="sng" algn="ctr">
-                      <a:solidFill>
-                        <a:srgbClr val="948A54"/>
-                      </a:solidFill>
-                      <a:prstDash val="dash"/>
-                      <a:round/>
-                      <a:headEnd type="none" w="med" len="med"/>
-                      <a:tailEnd type="none" w="med" len="med"/>
-                    </a:lnB>
-                    <a:lnTlToBr w="12700" cmpd="sng">
-                      <a:noFill/>
-                      <a:prstDash val="solid"/>
-                    </a:lnTlToBr>
-                    <a:lnBlToTr w="12700" cmpd="sng">
-                      <a:noFill/>
-                      <a:prstDash val="solid"/>
-                    </a:lnBlToTr>
-                    <a:solidFill>
-                      <a:srgbClr val="FFF2CC"/>
-                    </a:solidFill>
-                  </a:tcPr>
-                </a:tc>
-                <a:tc hMerge="1">
-                  <a:tcPr/>
-                </a:tc>
-                <a:tc hMerge="1">
-                  <a:tcPr/>
-                </a:tc>
-                <a:tc hMerge="1">
-                  <a:tcPr/>
-                </a:tc>
-                <a:tc hMerge="1">
-                  <a:tcPr/>
                 </a:tc>
               </a:tr>
               <a:tr h="482600">
@@ -4280,7 +4189,7 @@
                     </a:lnBlToTr>
                   </a:tcPr>
                 </a:tc>
-                <a:tc rowSpan="9">
+                <a:tc rowSpan="10">
                   <a:txBody>
                     <a:bodyPr/>
                     <a:p>
@@ -4980,7 +4889,7 @@
                   </a:tcPr>
                 </a:tc>
               </a:tr>
-              <a:tr h="325755">
+              <a:tr h="325120">
                 <a:tc>
                   <a:txBody>
                     <a:bodyPr/>
@@ -5315,7 +5224,7 @@
                   </a:tcPr>
                 </a:tc>
               </a:tr>
-              <a:tr h="321945">
+              <a:tr h="321310">
                 <a:tc gridSpan="4">
                   <a:txBody>
                     <a:bodyPr/>
@@ -5582,7 +5491,7 @@
                   </a:tcPr>
                 </a:tc>
               </a:tr>
-              <a:tr h="317500">
+              <a:tr h="316865">
                 <a:tc>
                   <a:txBody>
                     <a:bodyPr/>
@@ -5895,7 +5804,241 @@
                   </a:tcPr>
                 </a:tc>
               </a:tr>
-              <a:tr h="527050">
+              <a:tr h="231775">
+                <a:tc gridSpan="4">
+                  <a:txBody>
+                    <a:bodyPr/>
+                    <a:p>
+                      <a:pPr algn="ctr" fontAlgn="ctr">
+                        <a:buNone/>
+                      </a:pPr>
+                      <a:r>
+                        <a:rPr lang="en-US" sz="1050" b="1" dirty="0">
+                          <a:solidFill>
+                            <a:srgbClr val="000000"/>
+                          </a:solidFill>
+                          <a:effectLst/>
+                          <a:latin typeface="微软雅黑" charset="-122"/>
+                          <a:ea typeface="微软雅黑" charset="-122"/>
+                          <a:sym typeface="+mn-ea"/>
+                        </a:rPr>
+                        <a:t>Pony Class</a:t>
+                      </a:r>
+                      <a:endParaRPr lang="zh-CN" altLang="en-US" sz="1050" b="0" i="0" u="none" strike="noStrike" dirty="0">
+                        <a:solidFill>
+                          <a:schemeClr val="tx1"/>
+                        </a:solidFill>
+                        <a:effectLst/>
+                        <a:latin typeface="微软雅黑" charset="-122"/>
+                        <a:ea typeface="微软雅黑" charset="-122"/>
+                        <a:sym typeface="+mn-ea"/>
+                      </a:endParaRPr>
+                    </a:p>
+                  </a:txBody>
+                  <a:tcPr marL="2646" marR="2646" marT="2646" marB="0" anchor="ctr">
+                    <a:lnL w="12700" cap="flat" cmpd="sng" algn="ctr">
+                      <a:solidFill>
+                        <a:srgbClr val="948A54"/>
+                      </a:solidFill>
+                      <a:prstDash val="dash"/>
+                      <a:round/>
+                      <a:headEnd type="none" w="med" len="med"/>
+                      <a:tailEnd type="none" w="med" len="med"/>
+                    </a:lnL>
+                    <a:lnR w="12700" cap="flat" cmpd="sng" algn="ctr">
+                      <a:solidFill>
+                        <a:srgbClr val="948A54"/>
+                      </a:solidFill>
+                      <a:prstDash val="dash"/>
+                      <a:round/>
+                      <a:headEnd type="none" w="med" len="med"/>
+                      <a:tailEnd type="none" w="med" len="med"/>
+                    </a:lnR>
+                    <a:lnT w="12700" cap="flat" cmpd="sng" algn="ctr">
+                      <a:solidFill>
+                        <a:srgbClr val="948A54"/>
+                      </a:solidFill>
+                      <a:prstDash val="dash"/>
+                      <a:round/>
+                      <a:headEnd type="none" w="med" len="med"/>
+                      <a:tailEnd type="none" w="med" len="med"/>
+                    </a:lnT>
+                    <a:lnB w="12700" cap="flat" cmpd="sng" algn="ctr">
+                      <a:solidFill>
+                        <a:srgbClr val="948A54"/>
+                      </a:solidFill>
+                      <a:prstDash val="dash"/>
+                      <a:round/>
+                      <a:headEnd type="none" w="med" len="med"/>
+                      <a:tailEnd type="none" w="med" len="med"/>
+                    </a:lnB>
+                    <a:solidFill>
+                      <a:srgbClr val="FFF2CC"/>
+                    </a:solidFill>
+                  </a:tcPr>
+                </a:tc>
+                <a:tc hMerge="1">
+                  <a:tcPr marL="2646" marR="2646" marT="2646" marB="0" anchor="ctr">
+                    <a:lnL w="12700" cap="flat" cmpd="sng" algn="ctr">
+                      <a:solidFill>
+                        <a:srgbClr val="948A54"/>
+                      </a:solidFill>
+                      <a:prstDash val="dash"/>
+                      <a:round/>
+                      <a:headEnd type="none" w="med" len="med"/>
+                      <a:tailEnd type="none" w="med" len="med"/>
+                    </a:lnL>
+                    <a:lnR w="12700" cap="flat" cmpd="sng" algn="ctr">
+                      <a:solidFill>
+                        <a:srgbClr val="948A54"/>
+                      </a:solidFill>
+                      <a:prstDash val="dash"/>
+                      <a:round/>
+                      <a:headEnd type="none" w="med" len="med"/>
+                      <a:tailEnd type="none" w="med" len="med"/>
+                    </a:lnR>
+                    <a:lnT w="12700" cap="flat" cmpd="sng" algn="ctr">
+                      <a:solidFill>
+                        <a:srgbClr val="948A54"/>
+                      </a:solidFill>
+                      <a:prstDash val="dash"/>
+                      <a:round/>
+                      <a:headEnd type="none" w="med" len="med"/>
+                      <a:tailEnd type="none" w="med" len="med"/>
+                    </a:lnT>
+                    <a:lnB w="12700" cap="flat" cmpd="sng" algn="ctr">
+                      <a:solidFill>
+                        <a:srgbClr val="948A54"/>
+                      </a:solidFill>
+                      <a:prstDash val="dash"/>
+                      <a:round/>
+                      <a:headEnd type="none" w="med" len="med"/>
+                      <a:tailEnd type="none" w="med" len="med"/>
+                    </a:lnB>
+                  </a:tcPr>
+                </a:tc>
+                <a:tc hMerge="1">
+                  <a:tcPr marL="2646" marR="2646" marT="2646" marB="0" anchor="ctr">
+                    <a:lnL w="12700" cap="flat" cmpd="sng" algn="ctr">
+                      <a:solidFill>
+                        <a:srgbClr val="948A54"/>
+                      </a:solidFill>
+                      <a:prstDash val="dash"/>
+                      <a:round/>
+                      <a:headEnd type="none" w="med" len="med"/>
+                      <a:tailEnd type="none" w="med" len="med"/>
+                    </a:lnL>
+                    <a:lnR w="12700" cap="flat" cmpd="sng" algn="ctr">
+                      <a:solidFill>
+                        <a:srgbClr val="948A54"/>
+                      </a:solidFill>
+                      <a:prstDash val="dash"/>
+                      <a:round/>
+                      <a:headEnd type="none" w="med" len="med"/>
+                      <a:tailEnd type="none" w="med" len="med"/>
+                    </a:lnR>
+                    <a:lnT w="12700" cap="flat" cmpd="sng" algn="ctr">
+                      <a:solidFill>
+                        <a:srgbClr val="948A54"/>
+                      </a:solidFill>
+                      <a:prstDash val="dash"/>
+                      <a:round/>
+                      <a:headEnd type="none" w="med" len="med"/>
+                      <a:tailEnd type="none" w="med" len="med"/>
+                    </a:lnT>
+                    <a:lnB w="12700" cap="flat" cmpd="sng" algn="ctr">
+                      <a:solidFill>
+                        <a:srgbClr val="948A54"/>
+                      </a:solidFill>
+                      <a:prstDash val="dash"/>
+                      <a:round/>
+                      <a:headEnd type="none" w="med" len="med"/>
+                      <a:tailEnd type="none" w="med" len="med"/>
+                    </a:lnB>
+                  </a:tcPr>
+                </a:tc>
+                <a:tc hMerge="1">
+                  <a:tcPr marL="2646" marR="2646" marT="2646" marB="0" anchor="ctr">
+                    <a:lnL w="12700" cap="flat" cmpd="sng" algn="ctr">
+                      <a:solidFill>
+                        <a:srgbClr val="948A54"/>
+                      </a:solidFill>
+                      <a:prstDash val="dash"/>
+                      <a:round/>
+                      <a:headEnd type="none" w="med" len="med"/>
+                      <a:tailEnd type="none" w="med" len="med"/>
+                    </a:lnL>
+                    <a:lnR w="12700" cap="flat" cmpd="sng" algn="ctr">
+                      <a:solidFill>
+                        <a:srgbClr val="948A54"/>
+                      </a:solidFill>
+                      <a:prstDash val="dash"/>
+                      <a:round/>
+                      <a:headEnd type="none" w="med" len="med"/>
+                      <a:tailEnd type="none" w="med" len="med"/>
+                    </a:lnR>
+                    <a:lnT w="12700" cap="flat" cmpd="sng" algn="ctr">
+                      <a:solidFill>
+                        <a:srgbClr val="948A54"/>
+                      </a:solidFill>
+                      <a:prstDash val="dash"/>
+                      <a:round/>
+                      <a:headEnd type="none" w="med" len="med"/>
+                      <a:tailEnd type="none" w="med" len="med"/>
+                    </a:lnT>
+                    <a:lnB w="12700" cap="flat" cmpd="sng" algn="ctr">
+                      <a:solidFill>
+                        <a:srgbClr val="948A54"/>
+                      </a:solidFill>
+                      <a:prstDash val="dash"/>
+                      <a:round/>
+                      <a:headEnd type="none" w="med" len="med"/>
+                      <a:tailEnd type="none" w="med" len="med"/>
+                    </a:lnB>
+                  </a:tcPr>
+                </a:tc>
+                <a:tc vMerge="1">
+                  <a:tcPr marL="2646" marR="2646" marT="2646" marB="0" anchor="ctr">
+                    <a:lnL w="12700" cap="flat" cmpd="sng" algn="ctr">
+                      <a:solidFill>
+                        <a:srgbClr val="948A54"/>
+                      </a:solidFill>
+                      <a:prstDash val="dash"/>
+                      <a:round/>
+                      <a:headEnd type="none" w="med" len="med"/>
+                      <a:tailEnd type="none" w="med" len="med"/>
+                    </a:lnL>
+                    <a:lnR w="12700" cap="flat" cmpd="sng" algn="ctr">
+                      <a:solidFill>
+                        <a:srgbClr val="948A54"/>
+                      </a:solidFill>
+                      <a:prstDash val="dash"/>
+                      <a:round/>
+                      <a:headEnd type="none" w="med" len="med"/>
+                      <a:tailEnd type="none" w="med" len="med"/>
+                    </a:lnR>
+                    <a:lnT w="12700" cap="flat" cmpd="sng" algn="ctr">
+                      <a:solidFill>
+                        <a:srgbClr val="948A54"/>
+                      </a:solidFill>
+                      <a:prstDash val="dash"/>
+                      <a:round/>
+                      <a:headEnd type="none" w="med" len="med"/>
+                      <a:tailEnd type="none" w="med" len="med"/>
+                    </a:lnT>
+                    <a:lnB w="12700" cap="flat" cmpd="sng" algn="ctr">
+                      <a:solidFill>
+                        <a:srgbClr val="948A54"/>
+                      </a:solidFill>
+                      <a:prstDash val="dash"/>
+                      <a:round/>
+                      <a:headEnd type="none" w="med" len="med"/>
+                      <a:tailEnd type="none" w="med" len="med"/>
+                    </a:lnB>
+                  </a:tcPr>
+                </a:tc>
+              </a:tr>
+              <a:tr h="526415">
                 <a:tc>
                   <a:txBody>
                     <a:bodyPr/>
@@ -6114,12 +6257,7 @@
                       <a:headEnd type="none" w="med" len="med"/>
                       <a:tailEnd type="none" w="med" len="med"/>
                     </a:lnB>
-                    <a:solidFill>
-                      <a:schemeClr val="accent4">
-                        <a:lumMod val="20000"/>
-                        <a:lumOff val="80000"/>
-                      </a:schemeClr>
-                    </a:solidFill>
+                    <a:noFill/>
                   </a:tcPr>
                 </a:tc>
                 <a:tc>
@@ -6189,12 +6327,7 @@
                       <a:headEnd type="none" w="med" len="med"/>
                       <a:tailEnd type="none" w="med" len="med"/>
                     </a:lnB>
-                    <a:solidFill>
-                      <a:schemeClr val="accent4">
-                        <a:lumMod val="20000"/>
-                        <a:lumOff val="80000"/>
-                      </a:schemeClr>
-                    </a:solidFill>
+                    <a:noFill/>
                   </a:tcPr>
                 </a:tc>
                 <a:tc>
@@ -6301,12 +6434,7 @@
                       <a:headEnd type="none" w="med" len="med"/>
                       <a:tailEnd type="none" w="med" len="med"/>
                     </a:lnB>
-                    <a:solidFill>
-                      <a:schemeClr val="accent4">
-                        <a:lumMod val="20000"/>
-                        <a:lumOff val="80000"/>
-                      </a:schemeClr>
-                    </a:solidFill>
+                    <a:noFill/>
                   </a:tcPr>
                 </a:tc>
                 <a:tc>
@@ -6417,12 +6545,7 @@
                       <a:headEnd type="none" w="med" len="med"/>
                       <a:tailEnd type="none" w="med" len="med"/>
                     </a:lnB>
-                    <a:solidFill>
-                      <a:schemeClr val="accent4">
-                        <a:lumMod val="20000"/>
-                        <a:lumOff val="80000"/>
-                      </a:schemeClr>
-                    </a:solidFill>
+                    <a:noFill/>
                   </a:tcPr>
                 </a:tc>
                 <a:tc vMerge="1">
@@ -6472,7 +6595,7 @@
                   </a:tcPr>
                 </a:tc>
               </a:tr>
-              <a:tr h="450850">
+              <a:tr h="449580">
                 <a:tc>
                   <a:txBody>
                     <a:bodyPr/>
@@ -6578,6 +6701,9 @@
                       <a:headEnd type="none" w="med" len="med"/>
                       <a:tailEnd type="none" w="med" len="med"/>
                     </a:lnB>
+                    <a:solidFill>
+                      <a:srgbClr val="FFF2CC"/>
+                    </a:solidFill>
                   </a:tcPr>
                 </a:tc>
                 <a:tc>
@@ -6658,6 +6784,9 @@
                       <a:headEnd type="none" w="med" len="med"/>
                       <a:tailEnd type="none" w="med" len="med"/>
                     </a:lnB>
+                    <a:solidFill>
+                      <a:srgbClr val="FFF2CC"/>
+                    </a:solidFill>
                   </a:tcPr>
                 </a:tc>
                 <a:tc>
@@ -6773,6 +6902,9 @@
                       <a:headEnd type="none" w="med" len="med"/>
                       <a:tailEnd type="none" w="med" len="med"/>
                     </a:lnB>
+                    <a:solidFill>
+                      <a:srgbClr val="FFF2CC"/>
+                    </a:solidFill>
                   </a:tcPr>
                 </a:tc>
                 <a:tc>
@@ -6871,6 +7003,9 @@
                       <a:headEnd type="none" w="med" len="med"/>
                       <a:tailEnd type="none" w="med" len="med"/>
                     </a:lnB>
+                    <a:solidFill>
+                      <a:srgbClr val="FFF2CC"/>
+                    </a:solidFill>
                   </a:tcPr>
                 </a:tc>
                 <a:tc vMerge="1">
@@ -7064,9 +7199,7 @@
                       <a:headEnd type="none" w="med" len="med"/>
                       <a:tailEnd type="none" w="med" len="med"/>
                     </a:lnB>
-                    <a:solidFill>
-                      <a:srgbClr val="FFF2CC"/>
-                    </a:solidFill>
+                    <a:noFill/>
                   </a:tcPr>
                 </a:tc>
                 <a:tc>
@@ -7193,9 +7326,7 @@
                       <a:headEnd type="none" w="med" len="med"/>
                       <a:tailEnd type="none" w="med" len="med"/>
                     </a:lnB>
-                    <a:solidFill>
-                      <a:srgbClr val="FFF2CC"/>
-                    </a:solidFill>
+                    <a:noFill/>
                   </a:tcPr>
                 </a:tc>
                 <a:tc>
@@ -7338,9 +7469,7 @@
                       <a:headEnd type="none" w="med" len="med"/>
                       <a:tailEnd type="none" w="med" len="med"/>
                     </a:lnB>
-                    <a:solidFill>
-                      <a:srgbClr val="FFF2CC"/>
-                    </a:solidFill>
+                    <a:noFill/>
                   </a:tcPr>
                 </a:tc>
                 <a:tc>
@@ -7461,9 +7590,7 @@
                       <a:headEnd type="none" w="med" len="med"/>
                       <a:tailEnd type="none" w="med" len="med"/>
                     </a:lnB>
-                    <a:solidFill>
-                      <a:srgbClr val="FFF2CC"/>
-                    </a:solidFill>
+                    <a:noFill/>
                   </a:tcPr>
                 </a:tc>
                 <a:tc vMerge="1">
@@ -7507,7 +7634,7 @@
                   </a:tcPr>
                 </a:tc>
               </a:tr>
-              <a:tr h="313690">
+              <a:tr h="313055">
                 <a:tc gridSpan="4">
                   <a:txBody>
                     <a:bodyPr/>
@@ -7572,6 +7699,9 @@
                       <a:headEnd type="none" w="med" len="med"/>
                       <a:tailEnd type="none" w="med" len="med"/>
                     </a:lnB>
+                    <a:solidFill>
+                      <a:srgbClr val="FFF2CC"/>
+                    </a:solidFill>
                   </a:tcPr>
                 </a:tc>
                 <a:tc hMerge="1">
@@ -7800,12 +7930,7 @@
                       <a:headEnd type="none" w="med" len="med"/>
                       <a:tailEnd type="none" w="med" len="med"/>
                     </a:lnB>
-                    <a:solidFill>
-                      <a:schemeClr val="accent4">
-                        <a:lumMod val="20000"/>
-                        <a:lumOff val="80000"/>
-                      </a:schemeClr>
-                    </a:solidFill>
+                    <a:noFill/>
                   </a:tcPr>
                 </a:tc>
                 <a:tc hMerge="1">
@@ -7821,7 +7946,7 @@
                   <a:tcPr/>
                 </a:tc>
               </a:tr>
-              <a:tr h="177165">
+              <a:tr h="176530">
                 <a:tc gridSpan="5">
                   <a:txBody>
                     <a:bodyPr/>
@@ -7976,9 +8101,9 @@
 
 <file path=ppt/tags/tag5.xml><?xml version="1.0" encoding="utf-8"?>
 <p:tagLst xmlns:p="http://schemas.openxmlformats.org/presentationml/2006/main">
-  <p:tag name="KSO_WM_UNIT_TABLE_BEAUTIFY" val="smartTable{418dd55a-7418-4828-b1bc-64aa4fd4e99b}"/>
-  <p:tag name="TABLE_ENDDRAG_ORIGIN_RECT" val="927*368"/>
-  <p:tag name="TABLE_ENDDRAG_RECT" val="22*130*927*368"/>
+  <p:tag name="KSO_WM_UNIT_TABLE_BEAUTIFY" val="smartTable{575ff584-dbbc-42d3-9934-77630df53807}"/>
+  <p:tag name="TABLE_ENDDRAG_ORIGIN_RECT" val="927*375"/>
+  <p:tag name="TABLE_ENDDRAG_RECT" val="22*130*927*375"/>
 </p:tagLst>
 </file>
 

</xml_diff>